<commit_message>
realizing improvement in baseling of Cheng2020Anchor，conducting mAP datecting and RDDM improving for the first time，reaching the PSNR of 32.
</commit_message>
<xml_diff>
--- a/CRIS_week11.pptx
+++ b/CRIS_week11.pptx
@@ -8,6 +8,8 @@
     <p:sldId id="257" r:id="rId2"/>
     <p:sldId id="256" r:id="rId3"/>
     <p:sldId id="258" r:id="rId4"/>
+    <p:sldId id="259" r:id="rId5"/>
+    <p:sldId id="260" r:id="rId6"/>
   </p:sldIdLst>
   <p:sldSz cx="12192000" cy="6858000"/>
   <p:notesSz cx="6858000" cy="9144000"/>
@@ -106,6 +108,11 @@
       </a:defRPr>
     </a:lvl9pPr>
   </p:defaultTextStyle>
+  <p:extLst>
+    <p:ext uri="{EFAFB233-063F-42B5-8137-9DF3F51BA10A}">
+      <p15:sldGuideLst xmlns:p15="http://schemas.microsoft.com/office/powerpoint/2012/main"/>
+    </p:ext>
+  </p:extLst>
 </p:presentation>
 </file>
 
@@ -256,7 +263,7 @@
           <a:p>
             <a:fld id="{E5CFB802-0DEC-404F-A71A-B9CCB8AE4CE5}" type="datetimeFigureOut">
               <a:rPr lang="zh-CN" altLang="en-US" smtClean="0"/>
-              <a:t>2026/6/4</a:t>
+              <a:t>2026/6/5</a:t>
             </a:fld>
             <a:endParaRPr lang="zh-CN" altLang="en-US"/>
           </a:p>
@@ -454,7 +461,7 @@
           <a:p>
             <a:fld id="{E5CFB802-0DEC-404F-A71A-B9CCB8AE4CE5}" type="datetimeFigureOut">
               <a:rPr lang="zh-CN" altLang="en-US" smtClean="0"/>
-              <a:t>2026/6/4</a:t>
+              <a:t>2026/6/5</a:t>
             </a:fld>
             <a:endParaRPr lang="zh-CN" altLang="en-US"/>
           </a:p>
@@ -662,7 +669,7 @@
           <a:p>
             <a:fld id="{E5CFB802-0DEC-404F-A71A-B9CCB8AE4CE5}" type="datetimeFigureOut">
               <a:rPr lang="zh-CN" altLang="en-US" smtClean="0"/>
-              <a:t>2026/6/4</a:t>
+              <a:t>2026/6/5</a:t>
             </a:fld>
             <a:endParaRPr lang="zh-CN" altLang="en-US"/>
           </a:p>
@@ -860,7 +867,7 @@
           <a:p>
             <a:fld id="{E5CFB802-0DEC-404F-A71A-B9CCB8AE4CE5}" type="datetimeFigureOut">
               <a:rPr lang="zh-CN" altLang="en-US" smtClean="0"/>
-              <a:t>2026/6/4</a:t>
+              <a:t>2026/6/5</a:t>
             </a:fld>
             <a:endParaRPr lang="zh-CN" altLang="en-US"/>
           </a:p>
@@ -1135,7 +1142,7 @@
           <a:p>
             <a:fld id="{E5CFB802-0DEC-404F-A71A-B9CCB8AE4CE5}" type="datetimeFigureOut">
               <a:rPr lang="zh-CN" altLang="en-US" smtClean="0"/>
-              <a:t>2026/6/4</a:t>
+              <a:t>2026/6/5</a:t>
             </a:fld>
             <a:endParaRPr lang="zh-CN" altLang="en-US"/>
           </a:p>
@@ -1400,7 +1407,7 @@
           <a:p>
             <a:fld id="{E5CFB802-0DEC-404F-A71A-B9CCB8AE4CE5}" type="datetimeFigureOut">
               <a:rPr lang="zh-CN" altLang="en-US" smtClean="0"/>
-              <a:t>2026/6/4</a:t>
+              <a:t>2026/6/5</a:t>
             </a:fld>
             <a:endParaRPr lang="zh-CN" altLang="en-US"/>
           </a:p>
@@ -1812,7 +1819,7 @@
           <a:p>
             <a:fld id="{E5CFB802-0DEC-404F-A71A-B9CCB8AE4CE5}" type="datetimeFigureOut">
               <a:rPr lang="zh-CN" altLang="en-US" smtClean="0"/>
-              <a:t>2026/6/4</a:t>
+              <a:t>2026/6/5</a:t>
             </a:fld>
             <a:endParaRPr lang="zh-CN" altLang="en-US"/>
           </a:p>
@@ -1953,7 +1960,7 @@
           <a:p>
             <a:fld id="{E5CFB802-0DEC-404F-A71A-B9CCB8AE4CE5}" type="datetimeFigureOut">
               <a:rPr lang="zh-CN" altLang="en-US" smtClean="0"/>
-              <a:t>2026/6/4</a:t>
+              <a:t>2026/6/5</a:t>
             </a:fld>
             <a:endParaRPr lang="zh-CN" altLang="en-US"/>
           </a:p>
@@ -2066,7 +2073,7 @@
           <a:p>
             <a:fld id="{E5CFB802-0DEC-404F-A71A-B9CCB8AE4CE5}" type="datetimeFigureOut">
               <a:rPr lang="zh-CN" altLang="en-US" smtClean="0"/>
-              <a:t>2026/6/4</a:t>
+              <a:t>2026/6/5</a:t>
             </a:fld>
             <a:endParaRPr lang="zh-CN" altLang="en-US"/>
           </a:p>
@@ -2377,7 +2384,7 @@
           <a:p>
             <a:fld id="{E5CFB802-0DEC-404F-A71A-B9CCB8AE4CE5}" type="datetimeFigureOut">
               <a:rPr lang="zh-CN" altLang="en-US" smtClean="0"/>
-              <a:t>2026/6/4</a:t>
+              <a:t>2026/6/5</a:t>
             </a:fld>
             <a:endParaRPr lang="zh-CN" altLang="en-US"/>
           </a:p>
@@ -2665,7 +2672,7 @@
           <a:p>
             <a:fld id="{E5CFB802-0DEC-404F-A71A-B9CCB8AE4CE5}" type="datetimeFigureOut">
               <a:rPr lang="zh-CN" altLang="en-US" smtClean="0"/>
-              <a:t>2026/6/4</a:t>
+              <a:t>2026/6/5</a:t>
             </a:fld>
             <a:endParaRPr lang="zh-CN" altLang="en-US"/>
           </a:p>
@@ -2906,7 +2913,7 @@
           <a:p>
             <a:fld id="{E5CFB802-0DEC-404F-A71A-B9CCB8AE4CE5}" type="datetimeFigureOut">
               <a:rPr lang="zh-CN" altLang="en-US" smtClean="0"/>
-              <a:t>2026/6/4</a:t>
+              <a:t>2026/6/5</a:t>
             </a:fld>
             <a:endParaRPr lang="zh-CN" altLang="en-US"/>
           </a:p>
@@ -4081,7 +4088,7 @@
           <a:bodyPr/>
           <a:lstStyle/>
           <a:p>
-            <a:endParaRPr lang="zh-CN" altLang="en-US"/>
+            <a:endParaRPr lang="zh-CN" altLang="en-US" dirty="0"/>
           </a:p>
         </p:txBody>
       </p:sp>
@@ -4106,7 +4113,123 @@
           <a:bodyPr/>
           <a:lstStyle/>
           <a:p>
-            <a:endParaRPr lang="zh-CN" altLang="en-US"/>
+            <a:r>
+              <a:rPr lang="zh-CN" altLang="en-US" sz="2400" dirty="0"/>
+              <a:t>相较于</a:t>
+            </a:r>
+            <a:r>
+              <a:rPr lang="en-US" altLang="zh-CN" sz="2400" dirty="0" err="1"/>
+              <a:t>FactorizedPrior</a:t>
+            </a:r>
+            <a:r>
+              <a:rPr lang="zh-CN" altLang="en-US" sz="2400" dirty="0"/>
+              <a:t>，</a:t>
+            </a:r>
+            <a:r>
+              <a:rPr lang="en-US" altLang="zh-CN" sz="2400" dirty="0"/>
+              <a:t>Cheng2020Anchor</a:t>
+            </a:r>
+            <a:r>
+              <a:rPr lang="zh-CN" altLang="en-US" sz="2400" dirty="0"/>
+              <a:t>引入了高斯混合模型和自回归上下文模块，主干网络引入了</a:t>
+            </a:r>
+            <a:r>
+              <a:rPr lang="zh-CN" altLang="en-US" sz="2400" b="1" dirty="0"/>
+              <a:t>残差块</a:t>
+            </a:r>
+            <a:r>
+              <a:rPr lang="zh-CN" altLang="en-US" sz="2400" dirty="0"/>
+              <a:t>，特征提取能力更强，对火焰边缘这类高频细节的捕捉比纯卷积堆叠要好。</a:t>
+            </a:r>
+            <a:endParaRPr lang="en-US" altLang="zh-CN" sz="2400" dirty="0"/>
+          </a:p>
+          <a:p>
+            <a:r>
+              <a:rPr lang="en-US" altLang="zh-CN" sz="2400" dirty="0"/>
+              <a:t>Cheng2020Anchor</a:t>
+            </a:r>
+            <a:r>
+              <a:rPr lang="zh-CN" altLang="en-US" sz="2400" dirty="0"/>
+              <a:t>的</a:t>
+            </a:r>
+            <a:r>
+              <a:rPr lang="en-US" altLang="zh-CN" sz="2400" dirty="0"/>
+              <a:t>baseline</a:t>
+            </a:r>
+            <a:r>
+              <a:rPr lang="zh-CN" altLang="en-US" sz="2400" dirty="0"/>
+              <a:t>在</a:t>
+            </a:r>
+            <a:r>
+              <a:rPr lang="en-US" altLang="zh-CN" sz="2400" dirty="0"/>
+              <a:t>23</a:t>
+            </a:r>
+            <a:r>
+              <a:rPr lang="zh-CN" altLang="en-US" sz="2400" dirty="0"/>
+              <a:t>个</a:t>
+            </a:r>
+            <a:r>
+              <a:rPr lang="en-US" altLang="zh-CN" sz="2400" dirty="0"/>
+              <a:t>epoch</a:t>
+            </a:r>
+            <a:r>
+              <a:rPr lang="zh-CN" altLang="en-US" sz="2400" dirty="0"/>
+              <a:t>的时候就到了</a:t>
+            </a:r>
+            <a:r>
+              <a:rPr lang="en-US" altLang="zh-CN" sz="2400" dirty="0"/>
+              <a:t>PSNR27.4</a:t>
+            </a:r>
+            <a:r>
+              <a:rPr lang="zh-CN" altLang="en-US" sz="2400" dirty="0"/>
+              <a:t>，</a:t>
+            </a:r>
+            <a:r>
+              <a:rPr lang="en-US" altLang="zh-CN" sz="2400" dirty="0"/>
+              <a:t>bpp0.35</a:t>
+            </a:r>
+            <a:r>
+              <a:rPr lang="zh-CN" altLang="en-US" sz="2400" dirty="0"/>
+              <a:t>左右，但完整的训练流程没有跑完。不过我们可以看到在实现几乎相同的</a:t>
+            </a:r>
+            <a:r>
+              <a:rPr lang="en-US" altLang="zh-CN" sz="2400" dirty="0"/>
+              <a:t>PSNR</a:t>
+            </a:r>
+            <a:r>
+              <a:rPr lang="zh-CN" altLang="en-US" sz="2400" dirty="0"/>
+              <a:t>的前提下，新模型所占有的比特数少了一半。</a:t>
+            </a:r>
+            <a:endParaRPr lang="en-US" altLang="zh-CN" sz="2400" dirty="0"/>
+          </a:p>
+          <a:p>
+            <a:endParaRPr lang="en-US" altLang="zh-CN" sz="2400" dirty="0"/>
+          </a:p>
+          <a:p>
+            <a:r>
+              <a:rPr lang="zh-CN" altLang="en-US" sz="2400" dirty="0"/>
+              <a:t>下一步计划加入检测任务损失并引入</a:t>
+            </a:r>
+            <a:r>
+              <a:rPr lang="en-US" altLang="zh-CN" sz="2400" dirty="0"/>
+              <a:t>RDDM</a:t>
+            </a:r>
+            <a:r>
+              <a:rPr lang="zh-CN" altLang="en-US" sz="2400" dirty="0"/>
+              <a:t>，在 </a:t>
+            </a:r>
+            <a:r>
+              <a:rPr lang="en-US" altLang="zh-CN" sz="2400" dirty="0"/>
+              <a:t>Cheng2020 </a:t>
+            </a:r>
+            <a:r>
+              <a:rPr lang="zh-CN" altLang="en-US" sz="2400"/>
+              <a:t>重建结果的基础上，用残差扩散补回这些高频纹理细节。</a:t>
+            </a:r>
+            <a:endParaRPr lang="en-US" altLang="zh-CN" sz="2400" dirty="0"/>
+          </a:p>
+          <a:p>
+            <a:endParaRPr lang="zh-CN" altLang="en-US" dirty="0"/>
           </a:p>
         </p:txBody>
       </p:sp>
@@ -4114,6 +4237,166 @@
     <p:extLst>
       <p:ext uri="{BB962C8B-B14F-4D97-AF65-F5344CB8AC3E}">
         <p14:creationId xmlns:p14="http://schemas.microsoft.com/office/powerpoint/2010/main" val="327419509"/>
+      </p:ext>
+    </p:extLst>
+  </p:cSld>
+  <p:clrMapOvr>
+    <a:masterClrMapping/>
+  </p:clrMapOvr>
+</p:sld>
+</file>
+
+<file path=ppt/slides/slide4.xml><?xml version="1.0" encoding="utf-8"?>
+<p:sld xmlns:a="http://schemas.openxmlformats.org/drawingml/2006/main" xmlns:r="http://schemas.openxmlformats.org/officeDocument/2006/relationships" xmlns:p="http://schemas.openxmlformats.org/presentationml/2006/main">
+  <p:cSld>
+    <p:spTree>
+      <p:nvGrpSpPr>
+        <p:cNvPr id="1" name=""/>
+        <p:cNvGrpSpPr/>
+        <p:nvPr/>
+      </p:nvGrpSpPr>
+      <p:grpSpPr>
+        <a:xfrm>
+          <a:off x="0" y="0"/>
+          <a:ext cx="0" cy="0"/>
+          <a:chOff x="0" y="0"/>
+          <a:chExt cx="0" cy="0"/>
+        </a:xfrm>
+      </p:grpSpPr>
+      <p:sp>
+        <p:nvSpPr>
+          <p:cNvPr id="2" name="标题 1">
+            <a:extLst>
+              <a:ext uri="{FF2B5EF4-FFF2-40B4-BE49-F238E27FC236}">
+                <a16:creationId xmlns:a16="http://schemas.microsoft.com/office/drawing/2014/main" id="{A35D31DB-A8C6-D278-EF23-C9A88311E4E0}"/>
+              </a:ext>
+            </a:extLst>
+          </p:cNvPr>
+          <p:cNvSpPr>
+            <a:spLocks noGrp="1"/>
+          </p:cNvSpPr>
+          <p:nvPr>
+            <p:ph type="title"/>
+          </p:nvPr>
+        </p:nvSpPr>
+        <p:spPr/>
+        <p:txBody>
+          <a:bodyPr/>
+          <a:lstStyle/>
+          <a:p>
+            <a:endParaRPr lang="zh-CN" altLang="en-US"/>
+          </a:p>
+        </p:txBody>
+      </p:sp>
+      <p:sp>
+        <p:nvSpPr>
+          <p:cNvPr id="3" name="内容占位符 2">
+            <a:extLst>
+              <a:ext uri="{FF2B5EF4-FFF2-40B4-BE49-F238E27FC236}">
+                <a16:creationId xmlns:a16="http://schemas.microsoft.com/office/drawing/2014/main" id="{1C669F94-CDA0-E758-2CD1-2F1E452CF780}"/>
+              </a:ext>
+            </a:extLst>
+          </p:cNvPr>
+          <p:cNvSpPr>
+            <a:spLocks noGrp="1"/>
+          </p:cNvSpPr>
+          <p:nvPr>
+            <p:ph idx="1"/>
+          </p:nvPr>
+        </p:nvSpPr>
+        <p:spPr/>
+        <p:txBody>
+          <a:bodyPr/>
+          <a:lstStyle/>
+          <a:p>
+            <a:endParaRPr lang="zh-CN" altLang="en-US"/>
+          </a:p>
+        </p:txBody>
+      </p:sp>
+    </p:spTree>
+    <p:extLst>
+      <p:ext uri="{BB962C8B-B14F-4D97-AF65-F5344CB8AC3E}">
+        <p14:creationId xmlns:p14="http://schemas.microsoft.com/office/powerpoint/2010/main" val="4086509321"/>
+      </p:ext>
+    </p:extLst>
+  </p:cSld>
+  <p:clrMapOvr>
+    <a:masterClrMapping/>
+  </p:clrMapOvr>
+</p:sld>
+</file>
+
+<file path=ppt/slides/slide5.xml><?xml version="1.0" encoding="utf-8"?>
+<p:sld xmlns:a="http://schemas.openxmlformats.org/drawingml/2006/main" xmlns:r="http://schemas.openxmlformats.org/officeDocument/2006/relationships" xmlns:p="http://schemas.openxmlformats.org/presentationml/2006/main">
+  <p:cSld>
+    <p:spTree>
+      <p:nvGrpSpPr>
+        <p:cNvPr id="1" name=""/>
+        <p:cNvGrpSpPr/>
+        <p:nvPr/>
+      </p:nvGrpSpPr>
+      <p:grpSpPr>
+        <a:xfrm>
+          <a:off x="0" y="0"/>
+          <a:ext cx="0" cy="0"/>
+          <a:chOff x="0" y="0"/>
+          <a:chExt cx="0" cy="0"/>
+        </a:xfrm>
+      </p:grpSpPr>
+      <p:sp>
+        <p:nvSpPr>
+          <p:cNvPr id="2" name="标题 1">
+            <a:extLst>
+              <a:ext uri="{FF2B5EF4-FFF2-40B4-BE49-F238E27FC236}">
+                <a16:creationId xmlns:a16="http://schemas.microsoft.com/office/drawing/2014/main" id="{DCA837B4-57CE-841A-C666-138179397183}"/>
+              </a:ext>
+            </a:extLst>
+          </p:cNvPr>
+          <p:cNvSpPr>
+            <a:spLocks noGrp="1"/>
+          </p:cNvSpPr>
+          <p:nvPr>
+            <p:ph type="title"/>
+          </p:nvPr>
+        </p:nvSpPr>
+        <p:spPr/>
+        <p:txBody>
+          <a:bodyPr/>
+          <a:lstStyle/>
+          <a:p>
+            <a:endParaRPr lang="zh-CN" altLang="en-US"/>
+          </a:p>
+        </p:txBody>
+      </p:sp>
+      <p:sp>
+        <p:nvSpPr>
+          <p:cNvPr id="3" name="内容占位符 2">
+            <a:extLst>
+              <a:ext uri="{FF2B5EF4-FFF2-40B4-BE49-F238E27FC236}">
+                <a16:creationId xmlns:a16="http://schemas.microsoft.com/office/drawing/2014/main" id="{EBBFB129-A095-AB92-5AA9-F2198AC144F8}"/>
+              </a:ext>
+            </a:extLst>
+          </p:cNvPr>
+          <p:cNvSpPr>
+            <a:spLocks noGrp="1"/>
+          </p:cNvSpPr>
+          <p:nvPr>
+            <p:ph idx="1"/>
+          </p:nvPr>
+        </p:nvSpPr>
+        <p:spPr/>
+        <p:txBody>
+          <a:bodyPr/>
+          <a:lstStyle/>
+          <a:p>
+            <a:endParaRPr lang="zh-CN" altLang="en-US"/>
+          </a:p>
+        </p:txBody>
+      </p:sp>
+    </p:spTree>
+    <p:extLst>
+      <p:ext uri="{BB962C8B-B14F-4D97-AF65-F5344CB8AC3E}">
+        <p14:creationId xmlns:p14="http://schemas.microsoft.com/office/powerpoint/2010/main" val="3371898634"/>
       </p:ext>
     </p:extLst>
   </p:cSld>

</xml_diff>